<commit_message>
Give the second cover its own words, so the demo reads as a choice not a duplicate
The demo shows every layout exactly once, so both covers are in it - and with
the same title and subtitle on each they read as one slide pasted twice, which
is the opposite of the point. They carry different copy now: the paper cover
fronts a bid, the gradient one fronts a talk. A comment on each says a real deck
ships one and deletes the other.

Deleting the layout 20 slide instead would have cost the 1:1 parity with the
.potx and left preview/layout-20.png stale, since render_previews.py only writes
a preview for a layout the demo actually uses.

Both demos move together - scripts/build.py for the .pptx, web/demo/demo.tsx for
the React one. Templates rebuilt and checked; previews re-rendered.
</commit_message>
<xml_diff>
--- a/NCT-Slide-Template-Corp-Demo.pptx
+++ b/NCT-Slide-Template-Corp-Demo.pptx
@@ -22724,7 +22724,7 @@
             <a:pPr/>
             <a:r>
               <a:rPr lang="th-TH" dirty="0"/>
-              <a:t>ข้อเสนอโครงการวางระบบบัญชีอัตโนมัติ</a:t>
+              <a:t>เปลี่ยนงานบัญชีให้ระบบทำแทน</a:t>
             </a:r>
           </a:p>
         </p:txBody>
@@ -22747,7 +22747,7 @@
             <a:pPr/>
             <a:r>
               <a:rPr lang="th-TH" dirty="0"/>
-              <a:t>New Computer Technology Consulting Co., Ltd. · 2569</a:t>
+              <a:t>NCT · สัมมนาลูกค้า 2569</a:t>
             </a:r>
           </a:p>
         </p:txBody>

</xml_diff>